<commit_message>
chore(ai-lab-idc): refresh Word (from current 12-page proposal) + deck price to $300-350 all-in
</commit_message>
<xml_diff>
--- a/ai-lab-idc/Oakwood_AI_Lab_Chair_Deck.pptx
+++ b/ai-lab-idc/Oakwood_AI_Lab_Chair_Deck.pptx
@@ -3301,11 +3301,11 @@
             <a:pPr lvl="0"/>
             <a:r>
               <a:rPr b="1"/>
-              <a:t>Digital Pass $250–$350/student</a:t>
-            </a:r>
-            <a:r>
-              <a:rPr/>
-              <a:t> · textbook ~$35.</a:t>
+              <a:t>All-in student price $300–$350 / student</a:t>
+            </a:r>
+            <a:r>
+              <a:rPr/>
+              <a:t> (digital pass + course materials + the 2084 book, combined — no separate book charge).</a:t>
             </a:r>
           </a:p>
         </p:txBody>

</xml_diff>

<commit_message>
feat: 8+8 exhibits, 12-wk/2-ch curriculum + toolchain pricing, fix broken photo ref, ai-lab-final → Proposal Package primary CTA
</commit_message>
<xml_diff>
--- a/ai-lab-idc/Oakwood_AI_Lab_Chair_Deck.pptx
+++ b/ai-lab-idc/Oakwood_AI_Lab_Chair_Deck.pptx
@@ -3301,11 +3301,11 @@
             <a:pPr lvl="0"/>
             <a:r>
               <a:rPr b="1"/>
-              <a:t>All-in student price $300–$350 / student</a:t>
-            </a:r>
-            <a:r>
-              <a:rPr/>
-              <a:t> (digital pass + course materials + the 2084 book, combined — no separate book charge).</a:t>
+              <a:t>All-in $300–$350 / student</a:t>
+            </a:r>
+            <a:r>
+              <a:rPr/>
+              <a:t> — digital toolchain (ChatGPT + Claude + Gemini + Grok @ $20 each + OpenRouter $20 + Vercel + Supabase ≈ $200–250) + course materials + the 2084 book; every student ships 8 finished products.</a:t>
             </a:r>
           </a:p>
         </p:txBody>

</xml_diff>